<commit_message>
Regenerate Value Proposition and Curriculum deck deliverables
User reported the .pptx files as corrupted; regenerated both from
source (deck.js / build.js) and re-verified with the pptx skill's
schema validator, a LibreOffice PDF conversion, and a rendered check
slide from each before delivering. Content unchanged.

Co-Authored-By: Claude Sonnet 5 <noreply@anthropic.com>
Claude-Session: https://claude.ai/code/session_01Cm5htKGTSC5qKf9PgkxVGS
</commit_message>
<xml_diff>
--- a/deliverables/journi_Value_Proposition.pptx
+++ b/deliverables/journi_Value_Proposition.pptx
@@ -2588,7 +2588,7 @@
       </p:sp>
       <p:pic>
         <p:nvPicPr>
-          <p:cNvPr id="3" name="Image 0" descr="/home/user/scm-process-register/docs-src/pitch-deck/build/assets/compass.png">    </p:cNvPr>
+          <p:cNvPr id="3" name="Image 0" descr="/home/user/scm-process-register/docs-src/pitch-deck/assets/compass.png">    </p:cNvPr>
           <p:cNvPicPr>
             <a:picLocks noChangeAspect="1"/>
           </p:cNvPicPr>
@@ -2945,7 +2945,7 @@
       </p:sp>
       <p:pic>
         <p:nvPicPr>
-          <p:cNvPr id="6" name="Image 0" descr="/home/user/scm-process-register/docs-src/pitch-deck/build/assets/file-signature.png">    </p:cNvPr>
+          <p:cNvPr id="6" name="Image 0" descr="/home/user/scm-process-register/docs-src/pitch-deck/assets/file-signature.png">    </p:cNvPr>
           <p:cNvPicPr>
             <a:picLocks noChangeAspect="1"/>
           </p:cNvPicPr>
@@ -3095,7 +3095,7 @@
       </p:sp>
       <p:pic>
         <p:nvPicPr>
-          <p:cNvPr id="11" name="Image 1" descr="/home/user/scm-process-register/docs-src/pitch-deck/build/assets/chart-line.png">    </p:cNvPr>
+          <p:cNvPr id="11" name="Image 1" descr="/home/user/scm-process-register/docs-src/pitch-deck/assets/chart-line.png">    </p:cNvPr>
           <p:cNvPicPr>
             <a:picLocks noChangeAspect="1"/>
           </p:cNvPicPr>
@@ -3245,7 +3245,7 @@
       </p:sp>
       <p:pic>
         <p:nvPicPr>
-          <p:cNvPr id="16" name="Image 2" descr="/home/user/scm-process-register/docs-src/pitch-deck/build/assets/users-gear.png">    </p:cNvPr>
+          <p:cNvPr id="16" name="Image 2" descr="/home/user/scm-process-register/docs-src/pitch-deck/assets/users-gear.png">    </p:cNvPr>
           <p:cNvPicPr>
             <a:picLocks noChangeAspect="1"/>
           </p:cNvPicPr>
@@ -3395,7 +3395,7 @@
       </p:sp>
       <p:pic>
         <p:nvPicPr>
-          <p:cNvPr id="21" name="Image 3" descr="/home/user/scm-process-register/docs-src/pitch-deck/build/assets/shield-halved.png">    </p:cNvPr>
+          <p:cNvPr id="21" name="Image 3" descr="/home/user/scm-process-register/docs-src/pitch-deck/assets/shield-halved.png">    </p:cNvPr>
           <p:cNvPicPr>
             <a:picLocks noChangeAspect="1"/>
           </p:cNvPicPr>
@@ -3545,7 +3545,7 @@
       </p:sp>
       <p:pic>
         <p:nvPicPr>
-          <p:cNvPr id="26" name="Image 4" descr="/home/user/scm-process-register/docs-src/pitch-deck/build/assets/globe.png">    </p:cNvPr>
+          <p:cNvPr id="26" name="Image 4" descr="/home/user/scm-process-register/docs-src/pitch-deck/assets/globe.png">    </p:cNvPr>
           <p:cNvPicPr>
             <a:picLocks noChangeAspect="1"/>
           </p:cNvPicPr>
@@ -3695,7 +3695,7 @@
       </p:sp>
       <p:pic>
         <p:nvPicPr>
-          <p:cNvPr id="31" name="Image 5" descr="/home/user/scm-process-register/docs-src/pitch-deck/build/assets/server.png">    </p:cNvPr>
+          <p:cNvPr id="31" name="Image 5" descr="/home/user/scm-process-register/docs-src/pitch-deck/assets/server.png">    </p:cNvPr>
           <p:cNvPicPr>
             <a:picLocks noChangeAspect="1"/>
           </p:cNvPicPr>
@@ -4043,7 +4043,7 @@
       </p:sp>
       <p:pic>
         <p:nvPicPr>
-          <p:cNvPr id="6" name="Image 0" descr="/home/user/scm-process-register/docs-src/pitch-deck/build/assets/cubes.png">    </p:cNvPr>
+          <p:cNvPr id="6" name="Image 0" descr="/home/user/scm-process-register/docs-src/pitch-deck/assets/cubes.png">    </p:cNvPr>
           <p:cNvPicPr>
             <a:picLocks noChangeAspect="1"/>
           </p:cNvPicPr>
@@ -4343,7 +4343,7 @@
       </p:sp>
       <p:pic>
         <p:nvPicPr>
-          <p:cNvPr id="14" name="Image 1" descr="/home/user/scm-process-register/docs-src/pitch-deck/build/assets/user.png">    </p:cNvPr>
+          <p:cNvPr id="14" name="Image 1" descr="/home/user/scm-process-register/docs-src/pitch-deck/assets/user.png">    </p:cNvPr>
           <p:cNvPicPr>
             <a:picLocks noChangeAspect="1"/>
           </p:cNvPicPr>
@@ -4904,7 +4904,7 @@
       </p:sp>
       <p:pic>
         <p:nvPicPr>
-          <p:cNvPr id="7" name="Image 0" descr="/home/user/scm-process-register/docs-src/pitch-deck/build/assets/chart-line.png">    </p:cNvPr>
+          <p:cNvPr id="7" name="Image 0" descr="/home/user/scm-process-register/docs-src/pitch-deck/assets/chart-line.png">    </p:cNvPr>
           <p:cNvPicPr>
             <a:picLocks noChangeAspect="1"/>
           </p:cNvPicPr>
@@ -5100,7 +5100,7 @@
       </p:sp>
       <p:pic>
         <p:nvPicPr>
-          <p:cNvPr id="13" name="Image 1" descr="/home/user/scm-process-register/docs-src/pitch-deck/build/assets/building-columns.png">    </p:cNvPr>
+          <p:cNvPr id="13" name="Image 1" descr="/home/user/scm-process-register/docs-src/pitch-deck/assets/building-columns.png">    </p:cNvPr>
           <p:cNvPicPr>
             <a:picLocks noChangeAspect="1"/>
           </p:cNvPicPr>
@@ -5296,7 +5296,7 @@
       </p:sp>
       <p:pic>
         <p:nvPicPr>
-          <p:cNvPr id="19" name="Image 2" descr="/home/user/scm-process-register/docs-src/pitch-deck/build/assets/route.png">    </p:cNvPr>
+          <p:cNvPr id="19" name="Image 2" descr="/home/user/scm-process-register/docs-src/pitch-deck/assets/route.png">    </p:cNvPr>
           <p:cNvPicPr>
             <a:picLocks noChangeAspect="1"/>
           </p:cNvPicPr>
@@ -5492,7 +5492,7 @@
       </p:sp>
       <p:pic>
         <p:nvPicPr>
-          <p:cNvPr id="25" name="Image 3" descr="/home/user/scm-process-register/docs-src/pitch-deck/build/assets/heart.png">    </p:cNvPr>
+          <p:cNvPr id="25" name="Image 3" descr="/home/user/scm-process-register/docs-src/pitch-deck/assets/heart.png">    </p:cNvPr>
           <p:cNvPicPr>
             <a:picLocks noChangeAspect="1"/>
           </p:cNvPicPr>
@@ -5921,7 +5921,7 @@
       </p:sp>
       <p:pic>
         <p:nvPicPr>
-          <p:cNvPr id="7" name="Image 0" descr="/home/user/scm-process-register/docs-src/pitch-deck/build/assets/eye.png">    </p:cNvPr>
+          <p:cNvPr id="7" name="Image 0" descr="/home/user/scm-process-register/docs-src/pitch-deck/assets/eye.png">    </p:cNvPr>
           <p:cNvPicPr>
             <a:picLocks noChangeAspect="1"/>
           </p:cNvPicPr>
@@ -6075,7 +6075,7 @@
       </p:sp>
       <p:pic>
         <p:nvPicPr>
-          <p:cNvPr id="12" name="Image 1" descr="/home/user/scm-process-register/docs-src/pitch-deck/build/assets/pen-to-square.png">    </p:cNvPr>
+          <p:cNvPr id="12" name="Image 1" descr="/home/user/scm-process-register/docs-src/pitch-deck/assets/pen-to-square.png">    </p:cNvPr>
           <p:cNvPicPr>
             <a:picLocks noChangeAspect="1"/>
           </p:cNvPicPr>
@@ -6229,7 +6229,7 @@
       </p:sp>
       <p:pic>
         <p:nvPicPr>
-          <p:cNvPr id="17" name="Image 2" descr="/home/user/scm-process-register/docs-src/pitch-deck/build/assets/ban.png">    </p:cNvPr>
+          <p:cNvPr id="17" name="Image 2" descr="/home/user/scm-process-register/docs-src/pitch-deck/assets/ban.png">    </p:cNvPr>
           <p:cNvPicPr>
             <a:picLocks noChangeAspect="1"/>
           </p:cNvPicPr>
@@ -6638,7 +6638,7 @@
       </p:sp>
       <p:pic>
         <p:nvPicPr>
-          <p:cNvPr id="6" name="Image 0" descr="/home/user/scm-process-register/docs-src/pitch-deck/build/assets/sitemap.png">    </p:cNvPr>
+          <p:cNvPr id="6" name="Image 0" descr="/home/user/scm-process-register/docs-src/pitch-deck/assets/sitemap.png">    </p:cNvPr>
           <p:cNvPicPr>
             <a:picLocks noChangeAspect="1"/>
           </p:cNvPicPr>
@@ -6788,7 +6788,7 @@
       </p:sp>
       <p:pic>
         <p:nvPicPr>
-          <p:cNvPr id="11" name="Image 1" descr="/home/user/scm-process-register/docs-src/pitch-deck/build/assets/users-gear.png">    </p:cNvPr>
+          <p:cNvPr id="11" name="Image 1" descr="/home/user/scm-process-register/docs-src/pitch-deck/assets/users-gear.png">    </p:cNvPr>
           <p:cNvPicPr>
             <a:picLocks noChangeAspect="1"/>
           </p:cNvPicPr>
@@ -6938,7 +6938,7 @@
       </p:sp>
       <p:pic>
         <p:nvPicPr>
-          <p:cNvPr id="16" name="Image 2" descr="/home/user/scm-process-register/docs-src/pitch-deck/build/assets/file-signature.png">    </p:cNvPr>
+          <p:cNvPr id="16" name="Image 2" descr="/home/user/scm-process-register/docs-src/pitch-deck/assets/file-signature.png">    </p:cNvPr>
           <p:cNvPicPr>
             <a:picLocks noChangeAspect="1"/>
           </p:cNvPicPr>
@@ -7088,7 +7088,7 @@
       </p:sp>
       <p:pic>
         <p:nvPicPr>
-          <p:cNvPr id="21" name="Image 3" descr="/home/user/scm-process-register/docs-src/pitch-deck/build/assets/server.png">    </p:cNvPr>
+          <p:cNvPr id="21" name="Image 3" descr="/home/user/scm-process-register/docs-src/pitch-deck/assets/server.png">    </p:cNvPr>
           <p:cNvPicPr>
             <a:picLocks noChangeAspect="1"/>
           </p:cNvPicPr>
@@ -7471,7 +7471,7 @@
       </p:sp>
       <p:pic>
         <p:nvPicPr>
-          <p:cNvPr id="7" name="Image 0" descr="/home/user/scm-process-register/docs-src/pitch-deck/build/assets/rocket.png">    </p:cNvPr>
+          <p:cNvPr id="7" name="Image 0" descr="/home/user/scm-process-register/docs-src/pitch-deck/assets/rocket.png">    </p:cNvPr>
           <p:cNvPicPr>
             <a:picLocks noChangeAspect="1"/>
           </p:cNvPicPr>
@@ -7579,7 +7579,7 @@
       </p:sp>
       <p:pic>
         <p:nvPicPr>
-          <p:cNvPr id="11" name="Image 1" descr="/home/user/scm-process-register/docs-src/pitch-deck/build/assets/robot.png">    </p:cNvPr>
+          <p:cNvPr id="11" name="Image 1" descr="/home/user/scm-process-register/docs-src/pitch-deck/assets/robot.png">    </p:cNvPr>
           <p:cNvPicPr>
             <a:picLocks noChangeAspect="1"/>
           </p:cNvPicPr>
@@ -7687,7 +7687,7 @@
       </p:sp>
       <p:pic>
         <p:nvPicPr>
-          <p:cNvPr id="15" name="Image 2" descr="/home/user/scm-process-register/docs-src/pitch-deck/build/assets/certificate.png">    </p:cNvPr>
+          <p:cNvPr id="15" name="Image 2" descr="/home/user/scm-process-register/docs-src/pitch-deck/assets/certificate.png">    </p:cNvPr>
           <p:cNvPicPr>
             <a:picLocks noChangeAspect="1"/>
           </p:cNvPicPr>
@@ -7795,7 +7795,7 @@
       </p:sp>
       <p:pic>
         <p:nvPicPr>
-          <p:cNvPr id="19" name="Image 3" descr="/home/user/scm-process-register/docs-src/pitch-deck/build/assets/diagram-project.png">    </p:cNvPr>
+          <p:cNvPr id="19" name="Image 3" descr="/home/user/scm-process-register/docs-src/pitch-deck/assets/diagram-project.png">    </p:cNvPr>
           <p:cNvPicPr>
             <a:picLocks noChangeAspect="1"/>
           </p:cNvPicPr>
@@ -7903,7 +7903,7 @@
       </p:sp>
       <p:pic>
         <p:nvPicPr>
-          <p:cNvPr id="23" name="Image 4" descr="/home/user/scm-process-register/docs-src/pitch-deck/build/assets/building-columns.png">    </p:cNvPr>
+          <p:cNvPr id="23" name="Image 4" descr="/home/user/scm-process-register/docs-src/pitch-deck/assets/building-columns.png">    </p:cNvPr>
           <p:cNvPicPr>
             <a:picLocks noChangeAspect="1"/>
           </p:cNvPicPr>
@@ -8011,7 +8011,7 @@
       </p:sp>
       <p:pic>
         <p:nvPicPr>
-          <p:cNvPr id="27" name="Image 5" descr="/home/user/scm-process-register/docs-src/pitch-deck/build/assets/people-group.png">    </p:cNvPr>
+          <p:cNvPr id="27" name="Image 5" descr="/home/user/scm-process-register/docs-src/pitch-deck/assets/people-group.png">    </p:cNvPr>
           <p:cNvPicPr>
             <a:picLocks noChangeAspect="1"/>
           </p:cNvPicPr>
@@ -8119,7 +8119,7 @@
       </p:sp>
       <p:pic>
         <p:nvPicPr>
-          <p:cNvPr id="31" name="Image 6" descr="/home/user/scm-process-register/docs-src/pitch-deck/build/assets/scale-balanced.png">    </p:cNvPr>
+          <p:cNvPr id="31" name="Image 6" descr="/home/user/scm-process-register/docs-src/pitch-deck/assets/scale-balanced.png">    </p:cNvPr>
           <p:cNvPicPr>
             <a:picLocks noChangeAspect="1"/>
           </p:cNvPicPr>
@@ -8227,7 +8227,7 @@
       </p:sp>
       <p:pic>
         <p:nvPicPr>
-          <p:cNvPr id="35" name="Image 7" descr="/home/user/scm-process-register/docs-src/pitch-deck/build/assets/graduation-cap.png">    </p:cNvPr>
+          <p:cNvPr id="35" name="Image 7" descr="/home/user/scm-process-register/docs-src/pitch-deck/assets/graduation-cap.png">    </p:cNvPr>
           <p:cNvPicPr>
             <a:picLocks noChangeAspect="1"/>
           </p:cNvPicPr>
@@ -8381,7 +8381,7 @@
       </p:sp>
       <p:pic>
         <p:nvPicPr>
-          <p:cNvPr id="40" name="Image 8" descr="/home/user/scm-process-register/docs-src/pitch-deck/build/assets/industry.png">    </p:cNvPr>
+          <p:cNvPr id="40" name="Image 8" descr="/home/user/scm-process-register/docs-src/pitch-deck/assets/industry.png">    </p:cNvPr>
           <p:cNvPicPr>
             <a:picLocks noChangeAspect="1"/>
           </p:cNvPicPr>
@@ -8493,7 +8493,7 @@
       </p:sp>
       <p:pic>
         <p:nvPicPr>
-          <p:cNvPr id="44" name="Image 9" descr="/home/user/scm-process-register/docs-src/pitch-deck/build/assets/truck.png">    </p:cNvPr>
+          <p:cNvPr id="44" name="Image 9" descr="/home/user/scm-process-register/docs-src/pitch-deck/assets/truck.png">    </p:cNvPr>
           <p:cNvPicPr>
             <a:picLocks noChangeAspect="1"/>
           </p:cNvPicPr>
@@ -8605,7 +8605,7 @@
       </p:sp>
       <p:pic>
         <p:nvPicPr>
-          <p:cNvPr id="48" name="Image 10" descr="/home/user/scm-process-register/docs-src/pitch-deck/build/assets/heart-pulse.png">    </p:cNvPr>
+          <p:cNvPr id="48" name="Image 10" descr="/home/user/scm-process-register/docs-src/pitch-deck/assets/heart-pulse.png">    </p:cNvPr>
           <p:cNvPicPr>
             <a:picLocks noChangeAspect="1"/>
           </p:cNvPicPr>
@@ -11338,7 +11338,7 @@
       </p:sp>
       <p:pic>
         <p:nvPicPr>
-          <p:cNvPr id="7" name="Image 0" descr="/home/user/scm-process-register/docs-src/pitch-deck/build/assets/triangle-exclamation.png">    </p:cNvPr>
+          <p:cNvPr id="7" name="Image 0" descr="/home/user/scm-process-register/docs-src/pitch-deck/assets/triangle-exclamation.png">    </p:cNvPr>
           <p:cNvPicPr>
             <a:picLocks noChangeAspect="1"/>
           </p:cNvPicPr>
@@ -11495,7 +11495,7 @@
       </p:sp>
       <p:pic>
         <p:nvPicPr>
-          <p:cNvPr id="12" name="Image 1" descr="/home/user/scm-process-register/docs-src/pitch-deck/build/assets/bolt.png">    </p:cNvPr>
+          <p:cNvPr id="12" name="Image 1" descr="/home/user/scm-process-register/docs-src/pitch-deck/assets/bolt.png">    </p:cNvPr>
           <p:cNvPicPr>
             <a:picLocks noChangeAspect="1"/>
           </p:cNvPicPr>
@@ -11652,7 +11652,7 @@
       </p:sp>
       <p:pic>
         <p:nvPicPr>
-          <p:cNvPr id="17" name="Image 2" descr="/home/user/scm-process-register/docs-src/pitch-deck/build/assets/gavel.png">    </p:cNvPr>
+          <p:cNvPr id="17" name="Image 2" descr="/home/user/scm-process-register/docs-src/pitch-deck/assets/gavel.png">    </p:cNvPr>
           <p:cNvPicPr>
             <a:picLocks noChangeAspect="1"/>
           </p:cNvPicPr>
@@ -11809,7 +11809,7 @@
       </p:sp>
       <p:pic>
         <p:nvPicPr>
-          <p:cNvPr id="22" name="Image 3" descr="/home/user/scm-process-register/docs-src/pitch-deck/build/assets/arrow-trend-up.png">    </p:cNvPr>
+          <p:cNvPr id="22" name="Image 3" descr="/home/user/scm-process-register/docs-src/pitch-deck/assets/arrow-trend-up.png">    </p:cNvPr>
           <p:cNvPicPr>
             <a:picLocks noChangeAspect="1"/>
           </p:cNvPicPr>
@@ -12125,7 +12125,7 @@
       </p:sp>
       <p:pic>
         <p:nvPicPr>
-          <p:cNvPr id="5" name="Image 0" descr="/home/user/scm-process-register/docs-src/pitch-deck/build/assets/check.png">    </p:cNvPr>
+          <p:cNvPr id="5" name="Image 0" descr="/home/user/scm-process-register/docs-src/pitch-deck/assets/check.png">    </p:cNvPr>
           <p:cNvPicPr>
             <a:picLocks noChangeAspect="1"/>
           </p:cNvPicPr>
@@ -12211,7 +12211,7 @@
       </p:sp>
       <p:pic>
         <p:nvPicPr>
-          <p:cNvPr id="8" name="Image 1" descr="/home/user/scm-process-register/docs-src/pitch-deck/build/assets/check.png">    </p:cNvPr>
+          <p:cNvPr id="8" name="Image 1" descr="/home/user/scm-process-register/docs-src/pitch-deck/assets/check.png">    </p:cNvPr>
           <p:cNvPicPr>
             <a:picLocks noChangeAspect="1"/>
           </p:cNvPicPr>
@@ -12297,7 +12297,7 @@
       </p:sp>
       <p:pic>
         <p:nvPicPr>
-          <p:cNvPr id="11" name="Image 2" descr="/home/user/scm-process-register/docs-src/pitch-deck/build/assets/check.png">    </p:cNvPr>
+          <p:cNvPr id="11" name="Image 2" descr="/home/user/scm-process-register/docs-src/pitch-deck/assets/check.png">    </p:cNvPr>
           <p:cNvPicPr>
             <a:picLocks noChangeAspect="1"/>
           </p:cNvPicPr>
@@ -12383,7 +12383,7 @@
       </p:sp>
       <p:pic>
         <p:nvPicPr>
-          <p:cNvPr id="14" name="Image 3" descr="/home/user/scm-process-register/docs-src/pitch-deck/build/assets/check.png">    </p:cNvPr>
+          <p:cNvPr id="14" name="Image 3" descr="/home/user/scm-process-register/docs-src/pitch-deck/assets/check.png">    </p:cNvPr>
           <p:cNvPicPr>
             <a:picLocks noChangeAspect="1"/>
           </p:cNvPicPr>
@@ -12469,7 +12469,7 @@
       </p:sp>
       <p:pic>
         <p:nvPicPr>
-          <p:cNvPr id="17" name="Image 4" descr="/home/user/scm-process-register/docs-src/pitch-deck/build/assets/check.png">    </p:cNvPr>
+          <p:cNvPr id="17" name="Image 4" descr="/home/user/scm-process-register/docs-src/pitch-deck/assets/check.png">    </p:cNvPr>
           <p:cNvPicPr>
             <a:picLocks noChangeAspect="1"/>
           </p:cNvPicPr>
@@ -12555,7 +12555,7 @@
       </p:sp>
       <p:pic>
         <p:nvPicPr>
-          <p:cNvPr id="20" name="Image 5" descr="/home/user/scm-process-register/docs-src/pitch-deck/build/assets/check.png">    </p:cNvPr>
+          <p:cNvPr id="20" name="Image 5" descr="/home/user/scm-process-register/docs-src/pitch-deck/assets/check.png">    </p:cNvPr>
           <p:cNvPicPr>
             <a:picLocks noChangeAspect="1"/>
           </p:cNvPicPr>
@@ -12900,7 +12900,7 @@
       </p:sp>
       <p:pic>
         <p:nvPicPr>
-          <p:cNvPr id="7" name="Image 0" descr="/home/user/scm-process-register/docs-src/pitch-deck/build/assets/seedling.png">    </p:cNvPr>
+          <p:cNvPr id="7" name="Image 0" descr="/home/user/scm-process-register/docs-src/pitch-deck/assets/seedling.png">    </p:cNvPr>
           <p:cNvPicPr>
             <a:picLocks noChangeAspect="1"/>
           </p:cNvPicPr>
@@ -13096,7 +13096,7 @@
       </p:sp>
       <p:pic>
         <p:nvPicPr>
-          <p:cNvPr id="13" name="Image 1" descr="/home/user/scm-process-register/docs-src/pitch-deck/build/assets/calendar-check.png">    </p:cNvPr>
+          <p:cNvPr id="13" name="Image 1" descr="/home/user/scm-process-register/docs-src/pitch-deck/assets/calendar-check.png">    </p:cNvPr>
           <p:cNvPicPr>
             <a:picLocks noChangeAspect="1"/>
           </p:cNvPicPr>
@@ -13292,7 +13292,7 @@
       </p:sp>
       <p:pic>
         <p:nvPicPr>
-          <p:cNvPr id="19" name="Image 2" descr="/home/user/scm-process-register/docs-src/pitch-deck/build/assets/scale-balanced.png">    </p:cNvPr>
+          <p:cNvPr id="19" name="Image 2" descr="/home/user/scm-process-register/docs-src/pitch-deck/assets/scale-balanced.png">    </p:cNvPr>
           <p:cNvPicPr>
             <a:picLocks noChangeAspect="1"/>
           </p:cNvPicPr>
@@ -13789,7 +13789,7 @@
       </p:sp>
       <p:pic>
         <p:nvPicPr>
-          <p:cNvPr id="10" name="Image 0" descr="/home/user/scm-process-register/docs-src/pitch-deck/build/assets/triangle-exclamation.png">    </p:cNvPr>
+          <p:cNvPr id="10" name="Image 0" descr="/home/user/scm-process-register/docs-src/pitch-deck/assets/triangle-exclamation.png">    </p:cNvPr>
           <p:cNvPicPr>
             <a:picLocks noChangeAspect="1"/>
           </p:cNvPicPr>
@@ -13904,7 +13904,7 @@
       </p:sp>
       <p:pic>
         <p:nvPicPr>
-          <p:cNvPr id="14" name="Image 1" descr="/home/user/scm-process-register/docs-src/pitch-deck/build/assets/shuffle.png">    </p:cNvPr>
+          <p:cNvPr id="14" name="Image 1" descr="/home/user/scm-process-register/docs-src/pitch-deck/assets/shuffle.png">    </p:cNvPr>
           <p:cNvPicPr>
             <a:picLocks noChangeAspect="1"/>
           </p:cNvPicPr>
@@ -14019,7 +14019,7 @@
       </p:sp>
       <p:pic>
         <p:nvPicPr>
-          <p:cNvPr id="18" name="Image 2" descr="/home/user/scm-process-register/docs-src/pitch-deck/build/assets/ghost.png">    </p:cNvPr>
+          <p:cNvPr id="18" name="Image 2" descr="/home/user/scm-process-register/docs-src/pitch-deck/assets/ghost.png">    </p:cNvPr>
           <p:cNvPicPr>
             <a:picLocks noChangeAspect="1"/>
           </p:cNvPicPr>
@@ -14134,7 +14134,7 @@
       </p:sp>
       <p:pic>
         <p:nvPicPr>
-          <p:cNvPr id="22" name="Image 3" descr="/home/user/scm-process-register/docs-src/pitch-deck/build/assets/clock-rotate-left.png">    </p:cNvPr>
+          <p:cNvPr id="22" name="Image 3" descr="/home/user/scm-process-register/docs-src/pitch-deck/assets/clock-rotate-left.png">    </p:cNvPr>
           <p:cNvPicPr>
             <a:picLocks noChangeAspect="1"/>
           </p:cNvPicPr>
@@ -14330,7 +14330,7 @@
       </p:sp>
       <p:pic>
         <p:nvPicPr>
-          <p:cNvPr id="3" name="Image 0" descr="/home/user/scm-process-register/docs-src/pitch-deck/build/assets/paper-plane.png">    </p:cNvPr>
+          <p:cNvPr id="3" name="Image 0" descr="/home/user/scm-process-register/docs-src/pitch-deck/assets/paper-plane.png">    </p:cNvPr>
           <p:cNvPicPr>
             <a:picLocks noChangeAspect="1"/>
           </p:cNvPicPr>
@@ -14675,7 +14675,7 @@
       </p:sp>
       <p:pic>
         <p:nvPicPr>
-          <p:cNvPr id="7" name="Image 0" descr="/home/user/scm-process-register/docs-src/pitch-deck/build/assets/database.png">    </p:cNvPr>
+          <p:cNvPr id="7" name="Image 0" descr="/home/user/scm-process-register/docs-src/pitch-deck/assets/database.png">    </p:cNvPr>
           <p:cNvPicPr>
             <a:picLocks noChangeAspect="1"/>
           </p:cNvPicPr>
@@ -14829,7 +14829,7 @@
       </p:sp>
       <p:pic>
         <p:nvPicPr>
-          <p:cNvPr id="12" name="Image 1" descr="/home/user/scm-process-register/docs-src/pitch-deck/build/assets/sitemap.png">    </p:cNvPr>
+          <p:cNvPr id="12" name="Image 1" descr="/home/user/scm-process-register/docs-src/pitch-deck/assets/sitemap.png">    </p:cNvPr>
           <p:cNvPicPr>
             <a:picLocks noChangeAspect="1"/>
           </p:cNvPicPr>
@@ -14983,7 +14983,7 @@
       </p:sp>
       <p:pic>
         <p:nvPicPr>
-          <p:cNvPr id="17" name="Image 2" descr="/home/user/scm-process-register/docs-src/pitch-deck/build/assets/shield-halved.png">    </p:cNvPr>
+          <p:cNvPr id="17" name="Image 2" descr="/home/user/scm-process-register/docs-src/pitch-deck/assets/shield-halved.png">    </p:cNvPr>
           <p:cNvPicPr>
             <a:picLocks noChangeAspect="1"/>
           </p:cNvPicPr>
@@ -15338,7 +15338,7 @@
       </p:sp>
       <p:pic>
         <p:nvPicPr>
-          <p:cNvPr id="6" name="Image 0" descr="/home/user/scm-process-register/docs-src/pitch-deck/build/assets/building.png">    </p:cNvPr>
+          <p:cNvPr id="6" name="Image 0" descr="/home/user/scm-process-register/docs-src/pitch-deck/assets/building.png">    </p:cNvPr>
           <p:cNvPicPr>
             <a:picLocks noChangeAspect="1"/>
           </p:cNvPicPr>
@@ -15424,7 +15424,7 @@
       </p:sp>
       <p:pic>
         <p:nvPicPr>
-          <p:cNvPr id="9" name="Image 1" descr="/home/user/scm-process-register/docs-src/pitch-deck/build/assets/diagram-project.png">    </p:cNvPr>
+          <p:cNvPr id="9" name="Image 1" descr="/home/user/scm-process-register/docs-src/pitch-deck/assets/diagram-project.png">    </p:cNvPr>
           <p:cNvPicPr>
             <a:picLocks noChangeAspect="1"/>
           </p:cNvPicPr>
@@ -15510,7 +15510,7 @@
       </p:sp>
       <p:pic>
         <p:nvPicPr>
-          <p:cNvPr id="12" name="Image 2" descr="/home/user/scm-process-register/docs-src/pitch-deck/build/assets/industry.png">    </p:cNvPr>
+          <p:cNvPr id="12" name="Image 2" descr="/home/user/scm-process-register/docs-src/pitch-deck/assets/industry.png">    </p:cNvPr>
           <p:cNvPicPr>
             <a:picLocks noChangeAspect="1"/>
           </p:cNvPicPr>
@@ -15596,7 +15596,7 @@
       </p:sp>
       <p:pic>
         <p:nvPicPr>
-          <p:cNvPr id="15" name="Image 3" descr="/home/user/scm-process-register/docs-src/pitch-deck/build/assets/globe.png">    </p:cNvPr>
+          <p:cNvPr id="15" name="Image 3" descr="/home/user/scm-process-register/docs-src/pitch-deck/assets/globe.png">    </p:cNvPr>
           <p:cNvPicPr>
             <a:picLocks noChangeAspect="1"/>
           </p:cNvPicPr>
@@ -15750,7 +15750,7 @@
       </p:sp>
       <p:pic>
         <p:nvPicPr>
-          <p:cNvPr id="20" name="Image 4" descr="/home/user/scm-process-register/docs-src/pitch-deck/build/assets/user-tie.png">    </p:cNvPr>
+          <p:cNvPr id="20" name="Image 4" descr="/home/user/scm-process-register/docs-src/pitch-deck/assets/user-tie.png">    </p:cNvPr>
           <p:cNvPicPr>
             <a:picLocks noChangeAspect="1"/>
           </p:cNvPicPr>
@@ -15904,7 +15904,7 @@
       </p:sp>
       <p:pic>
         <p:nvPicPr>
-          <p:cNvPr id="25" name="Image 5" descr="/home/user/scm-process-register/docs-src/pitch-deck/build/assets/users-gear.png">    </p:cNvPr>
+          <p:cNvPr id="25" name="Image 5" descr="/home/user/scm-process-register/docs-src/pitch-deck/assets/users-gear.png">    </p:cNvPr>
           <p:cNvPicPr>
             <a:picLocks noChangeAspect="1"/>
           </p:cNvPicPr>
@@ -16058,7 +16058,7 @@
       </p:sp>
       <p:pic>
         <p:nvPicPr>
-          <p:cNvPr id="30" name="Image 6" descr="/home/user/scm-process-register/docs-src/pitch-deck/build/assets/chart-line.png">    </p:cNvPr>
+          <p:cNvPr id="30" name="Image 6" descr="/home/user/scm-process-register/docs-src/pitch-deck/assets/chart-line.png">    </p:cNvPr>
           <p:cNvPicPr>
             <a:picLocks noChangeAspect="1"/>
           </p:cNvPicPr>
@@ -16403,7 +16403,7 @@
       </p:sp>
       <p:pic>
         <p:nvPicPr>
-          <p:cNvPr id="6" name="Image 0" descr="/home/user/scm-process-register/docs-src/pitch-deck/build/assets/gear.png">    </p:cNvPr>
+          <p:cNvPr id="6" name="Image 0" descr="/home/user/scm-process-register/docs-src/pitch-deck/assets/gear.png">    </p:cNvPr>
           <p:cNvPicPr>
             <a:picLocks noChangeAspect="1"/>
           </p:cNvPicPr>
@@ -16810,7 +16810,7 @@
       </p:sp>
       <p:pic>
         <p:nvPicPr>
-          <p:cNvPr id="15" name="Image 1" descr="/home/user/scm-process-register/docs-src/pitch-deck/build/assets/comments.png">    </p:cNvPr>
+          <p:cNvPr id="15" name="Image 1" descr="/home/user/scm-process-register/docs-src/pitch-deck/assets/comments.png">    </p:cNvPr>
           <p:cNvPicPr>
             <a:picLocks noChangeAspect="1"/>
           </p:cNvPicPr>
@@ -17099,7 +17099,7 @@
       </p:sp>
       <p:pic>
         <p:nvPicPr>
-          <p:cNvPr id="22" name="Image 2" descr="/home/user/scm-process-register/docs-src/pitch-deck/build/assets/heart.png">    </p:cNvPr>
+          <p:cNvPr id="22" name="Image 2" descr="/home/user/scm-process-register/docs-src/pitch-deck/assets/heart.png">    </p:cNvPr>
           <p:cNvPicPr>
             <a:picLocks noChangeAspect="1"/>
           </p:cNvPicPr>
@@ -17513,7 +17513,7 @@
       </p:sp>
       <p:pic>
         <p:nvPicPr>
-          <p:cNvPr id="6" name="Image 0" descr="/home/user/scm-process-register/docs-src/pitch-deck/build/assets/xmark.png">    </p:cNvPr>
+          <p:cNvPr id="6" name="Image 0" descr="/home/user/scm-process-register/docs-src/pitch-deck/assets/xmark.png">    </p:cNvPr>
           <p:cNvPicPr>
             <a:picLocks noChangeAspect="1"/>
           </p:cNvPicPr>
@@ -17621,7 +17621,7 @@
       </p:sp>
       <p:pic>
         <p:nvPicPr>
-          <p:cNvPr id="10" name="Image 1" descr="/home/user/scm-process-register/docs-src/pitch-deck/build/assets/xmark.png">    </p:cNvPr>
+          <p:cNvPr id="10" name="Image 1" descr="/home/user/scm-process-register/docs-src/pitch-deck/assets/xmark.png">    </p:cNvPr>
           <p:cNvPicPr>
             <a:picLocks noChangeAspect="1"/>
           </p:cNvPicPr>
@@ -17729,7 +17729,7 @@
       </p:sp>
       <p:pic>
         <p:nvPicPr>
-          <p:cNvPr id="14" name="Image 2" descr="/home/user/scm-process-register/docs-src/pitch-deck/build/assets/xmark.png">    </p:cNvPr>
+          <p:cNvPr id="14" name="Image 2" descr="/home/user/scm-process-register/docs-src/pitch-deck/assets/xmark.png">    </p:cNvPr>
           <p:cNvPicPr>
             <a:picLocks noChangeAspect="1"/>
           </p:cNvPicPr>
@@ -17837,7 +17837,7 @@
       </p:sp>
       <p:pic>
         <p:nvPicPr>
-          <p:cNvPr id="18" name="Image 3" descr="/home/user/scm-process-register/docs-src/pitch-deck/build/assets/xmark.png">    </p:cNvPr>
+          <p:cNvPr id="18" name="Image 3" descr="/home/user/scm-process-register/docs-src/pitch-deck/assets/xmark.png">    </p:cNvPr>
           <p:cNvPicPr>
             <a:picLocks noChangeAspect="1"/>
           </p:cNvPicPr>
@@ -17945,7 +17945,7 @@
       </p:sp>
       <p:pic>
         <p:nvPicPr>
-          <p:cNvPr id="22" name="Image 4" descr="/home/user/scm-process-register/docs-src/pitch-deck/build/assets/xmark.png">    </p:cNvPr>
+          <p:cNvPr id="22" name="Image 4" descr="/home/user/scm-process-register/docs-src/pitch-deck/assets/xmark.png">    </p:cNvPr>
           <p:cNvPicPr>
             <a:picLocks noChangeAspect="1"/>
           </p:cNvPicPr>
@@ -18053,7 +18053,7 @@
       </p:sp>
       <p:pic>
         <p:nvPicPr>
-          <p:cNvPr id="26" name="Image 5" descr="/home/user/scm-process-register/docs-src/pitch-deck/build/assets/xmark.png">    </p:cNvPr>
+          <p:cNvPr id="26" name="Image 5" descr="/home/user/scm-process-register/docs-src/pitch-deck/assets/xmark.png">    </p:cNvPr>
           <p:cNvPicPr>
             <a:picLocks noChangeAspect="1"/>
           </p:cNvPicPr>
@@ -18352,7 +18352,7 @@
       </p:sp>
       <p:pic>
         <p:nvPicPr>
-          <p:cNvPr id="6" name="Image 0" descr="/home/user/scm-process-register/docs-src/pitch-deck/build/assets/check.png">    </p:cNvPr>
+          <p:cNvPr id="6" name="Image 0" descr="/home/user/scm-process-register/docs-src/pitch-deck/assets/check.png">    </p:cNvPr>
           <p:cNvPicPr>
             <a:picLocks noChangeAspect="1"/>
           </p:cNvPicPr>
@@ -18460,7 +18460,7 @@
       </p:sp>
       <p:pic>
         <p:nvPicPr>
-          <p:cNvPr id="10" name="Image 1" descr="/home/user/scm-process-register/docs-src/pitch-deck/build/assets/check.png">    </p:cNvPr>
+          <p:cNvPr id="10" name="Image 1" descr="/home/user/scm-process-register/docs-src/pitch-deck/assets/check.png">    </p:cNvPr>
           <p:cNvPicPr>
             <a:picLocks noChangeAspect="1"/>
           </p:cNvPicPr>
@@ -18568,7 +18568,7 @@
       </p:sp>
       <p:pic>
         <p:nvPicPr>
-          <p:cNvPr id="14" name="Image 2" descr="/home/user/scm-process-register/docs-src/pitch-deck/build/assets/check.png">    </p:cNvPr>
+          <p:cNvPr id="14" name="Image 2" descr="/home/user/scm-process-register/docs-src/pitch-deck/assets/check.png">    </p:cNvPr>
           <p:cNvPicPr>
             <a:picLocks noChangeAspect="1"/>
           </p:cNvPicPr>
@@ -18676,7 +18676,7 @@
       </p:sp>
       <p:pic>
         <p:nvPicPr>
-          <p:cNvPr id="18" name="Image 3" descr="/home/user/scm-process-register/docs-src/pitch-deck/build/assets/check.png">    </p:cNvPr>
+          <p:cNvPr id="18" name="Image 3" descr="/home/user/scm-process-register/docs-src/pitch-deck/assets/check.png">    </p:cNvPr>
           <p:cNvPicPr>
             <a:picLocks noChangeAspect="1"/>
           </p:cNvPicPr>
@@ -18784,7 +18784,7 @@
       </p:sp>
       <p:pic>
         <p:nvPicPr>
-          <p:cNvPr id="22" name="Image 4" descr="/home/user/scm-process-register/docs-src/pitch-deck/build/assets/check.png">    </p:cNvPr>
+          <p:cNvPr id="22" name="Image 4" descr="/home/user/scm-process-register/docs-src/pitch-deck/assets/check.png">    </p:cNvPr>
           <p:cNvPicPr>
             <a:picLocks noChangeAspect="1"/>
           </p:cNvPicPr>
@@ -18892,7 +18892,7 @@
       </p:sp>
       <p:pic>
         <p:nvPicPr>
-          <p:cNvPr id="26" name="Image 5" descr="/home/user/scm-process-register/docs-src/pitch-deck/build/assets/check.png">    </p:cNvPr>
+          <p:cNvPr id="26" name="Image 5" descr="/home/user/scm-process-register/docs-src/pitch-deck/assets/check.png">    </p:cNvPr>
           <p:cNvPicPr>
             <a:picLocks noChangeAspect="1"/>
           </p:cNvPicPr>
@@ -19240,7 +19240,7 @@
       </p:sp>
       <p:pic>
         <p:nvPicPr>
-          <p:cNvPr id="7" name="Image 0" descr="/home/user/scm-process-register/docs-src/pitch-deck/build/assets/layer-group.png">    </p:cNvPr>
+          <p:cNvPr id="7" name="Image 0" descr="/home/user/scm-process-register/docs-src/pitch-deck/assets/layer-group.png">    </p:cNvPr>
           <p:cNvPicPr>
             <a:picLocks noChangeAspect="1"/>
           </p:cNvPicPr>
@@ -19673,7 +19673,7 @@
       </p:sp>
       <p:pic>
         <p:nvPicPr>
-          <p:cNvPr id="17" name="Image 1" descr="/home/user/scm-process-register/docs-src/pitch-deck/build/assets/route.png">    </p:cNvPr>
+          <p:cNvPr id="17" name="Image 1" descr="/home/user/scm-process-register/docs-src/pitch-deck/assets/route.png">    </p:cNvPr>
           <p:cNvPicPr>
             <a:picLocks noChangeAspect="1"/>
           </p:cNvPicPr>
@@ -20817,7 +20817,7 @@
       </p:sp>
       <p:pic>
         <p:nvPicPr>
-          <p:cNvPr id="6" name="Image 0" descr="/home/user/scm-process-register/docs-src/pitch-deck/build/assets/layer-group.png">    </p:cNvPr>
+          <p:cNvPr id="6" name="Image 0" descr="/home/user/scm-process-register/docs-src/pitch-deck/assets/layer-group.png">    </p:cNvPr>
           <p:cNvPicPr>
             <a:picLocks noChangeAspect="1"/>
           </p:cNvPicPr>
@@ -20967,7 +20967,7 @@
       </p:sp>
       <p:pic>
         <p:nvPicPr>
-          <p:cNvPr id="11" name="Image 1" descr="/home/user/scm-process-register/docs-src/pitch-deck/build/assets/shuffle.png">    </p:cNvPr>
+          <p:cNvPr id="11" name="Image 1" descr="/home/user/scm-process-register/docs-src/pitch-deck/assets/shuffle.png">    </p:cNvPr>
           <p:cNvPicPr>
             <a:picLocks noChangeAspect="1"/>
           </p:cNvPicPr>
@@ -21117,7 +21117,7 @@
       </p:sp>
       <p:pic>
         <p:nvPicPr>
-          <p:cNvPr id="16" name="Image 2" descr="/home/user/scm-process-register/docs-src/pitch-deck/build/assets/ghost.png">    </p:cNvPr>
+          <p:cNvPr id="16" name="Image 2" descr="/home/user/scm-process-register/docs-src/pitch-deck/assets/ghost.png">    </p:cNvPr>
           <p:cNvPicPr>
             <a:picLocks noChangeAspect="1"/>
           </p:cNvPicPr>
@@ -21267,7 +21267,7 @@
       </p:sp>
       <p:pic>
         <p:nvPicPr>
-          <p:cNvPr id="21" name="Image 3" descr="/home/user/scm-process-register/docs-src/pitch-deck/build/assets/clock-rotate-left.png">    </p:cNvPr>
+          <p:cNvPr id="21" name="Image 3" descr="/home/user/scm-process-register/docs-src/pitch-deck/assets/clock-rotate-left.png">    </p:cNvPr>
           <p:cNvPicPr>
             <a:picLocks noChangeAspect="1"/>
           </p:cNvPicPr>
@@ -21417,7 +21417,7 @@
       </p:sp>
       <p:pic>
         <p:nvPicPr>
-          <p:cNvPr id="26" name="Image 4" descr="/home/user/scm-process-register/docs-src/pitch-deck/build/assets/shield-halved.png">    </p:cNvPr>
+          <p:cNvPr id="26" name="Image 4" descr="/home/user/scm-process-register/docs-src/pitch-deck/assets/shield-halved.png">    </p:cNvPr>
           <p:cNvPicPr>
             <a:picLocks noChangeAspect="1"/>
           </p:cNvPicPr>
@@ -21567,7 +21567,7 @@
       </p:sp>
       <p:pic>
         <p:nvPicPr>
-          <p:cNvPr id="31" name="Image 5" descr="/home/user/scm-process-register/docs-src/pitch-deck/build/assets/chart-line.png">    </p:cNvPr>
+          <p:cNvPr id="31" name="Image 5" descr="/home/user/scm-process-register/docs-src/pitch-deck/assets/chart-line.png">    </p:cNvPr>
           <p:cNvPicPr>
             <a:picLocks noChangeAspect="1"/>
           </p:cNvPicPr>

</xml_diff>